<commit_message>
deck: real phone screenshots on slides 1 and 6 (landing, collect, confirm, docket)
</commit_message>
<xml_diff>
--- a/docs/Nyaya-Ledger.pptx
+++ b/docs/Nyaya-Ledger.pptx
@@ -2370,96 +2370,56 @@
           </a:p>
         </p:txBody>
       </p:sp>
-      <p:sp>
-        <p:nvSpPr>
-          <p:cNvPr id="14" name="Text 11"/>
-          <p:cNvSpPr/>
-          <p:nvPr/>
-        </p:nvSpPr>
+      <p:pic>
+        <p:nvPicPr>
+          <p:cNvPr id="14" name="Image 1" descr="Hero screenshot">    </p:cNvPr>
+          <p:cNvPicPr>
+            <a:picLocks noChangeAspect="1"/>
+          </p:cNvPicPr>
+          <p:nvPr/>
+        </p:nvPicPr>
+        <p:blipFill>
+          <a:blip r:embed="rId4"/>
+          <a:stretch>
+            <a:fillRect/>
+          </a:stretch>
+        </p:blipFill>
         <p:spPr>
           <a:xfrm>
             <a:off x="8366760" y="914400"/>
-            <a:ext cx="2880360" cy="5394960"/>
-          </a:xfrm>
-          <a:prstGeom prst="roundRect">
-            <a:avLst>
-              <a:gd name="adj" fmla="val 3810"/>
-            </a:avLst>
+            <a:ext cx="2880360" cy="5101125"/>
+          </a:xfrm>
+          <a:prstGeom prst="rect">
+            <a:avLst/>
+          </a:prstGeom>
+        </p:spPr>
+      </p:pic>
+      <p:sp>
+        <p:nvSpPr>
+          <p:cNvPr id="15" name="Shape 11"/>
+          <p:cNvSpPr/>
+          <p:nvPr/>
+        </p:nvSpPr>
+        <p:spPr>
+          <a:xfrm>
+            <a:off x="8366760" y="914400"/>
+            <a:ext cx="2880360" cy="5101125"/>
+          </a:xfrm>
+          <a:prstGeom prst="rect">
+            <a:avLst/>
           </a:prstGeom>
           <a:solidFill>
-            <a:srgbClr val="F2F4F7"/>
+            <a:srgbClr val="FFFFFF">
+              <a:alpha val="0"/>
+            </a:srgbClr>
           </a:solidFill>
-          <a:ln w="12700">
+          <a:ln w="9525">
             <a:solidFill>
-              <a:srgbClr val="9AA4B2"/>
+              <a:srgbClr val="D9DEE4"/>
             </a:solidFill>
-            <a:prstDash val="dash"/>
+            <a:prstDash val="solid"/>
           </a:ln>
         </p:spPr>
-        <p:txBody>
-          <a:bodyPr wrap="square" lIns="101600" tIns="101600" rIns="101600" bIns="101600" rtlCol="0" anchor="ctr"/>
-          <a:lstStyle/>
-          <a:p>
-            <a:pPr algn="ctr" indent="0" marL="0">
-              <a:spcAft>
-                <a:spcPts val="400"/>
-              </a:spcAft>
-              <a:buNone/>
-            </a:pPr>
-            <a:r>
-              <a:rPr lang="en-US" sz="1200" dirty="0">
-                <a:solidFill>
-                  <a:srgbClr val="5B6470"/>
-                </a:solidFill>
-                <a:latin typeface="Segoe UI Semibold" pitchFamily="34" charset="0"/>
-                <a:ea typeface="Segoe UI Semibold" pitchFamily="34" charset="-122"/>
-                <a:cs typeface="Segoe UI Semibold" pitchFamily="34" charset="-120"/>
-              </a:rPr>
-              <a:t>Hero screenshot</a:t>
-            </a:r>
-            <a:endParaRPr lang="en-US" sz="1200" dirty="0"/>
-          </a:p>
-          <a:p>
-            <a:pPr algn="ctr" indent="0" marL="0">
-              <a:spcAft>
-                <a:spcPts val="400"/>
-              </a:spcAft>
-              <a:buNone/>
-            </a:pPr>
-            <a:r>
-              <a:rPr lang="en-US" sz="1000" dirty="0">
-                <a:solidFill>
-                  <a:srgbClr val="5B6470"/>
-                </a:solidFill>
-                <a:latin typeface="Segoe UI" pitchFamily="34" charset="0"/>
-                <a:ea typeface="Segoe UI" pitchFamily="34" charset="-122"/>
-                <a:cs typeface="Segoe UI" pitchFamily="34" charset="-120"/>
-              </a:rPr>
-              <a:t>Result screen in English: summary + first finding cards (phone, 412 px wide)</a:t>
-            </a:r>
-            <a:endParaRPr lang="en-US" sz="1200" dirty="0"/>
-          </a:p>
-          <a:p>
-            <a:pPr algn="ctr" indent="0" marL="0">
-              <a:spcAft>
-                <a:spcPts val="400"/>
-              </a:spcAft>
-              <a:buNone/>
-            </a:pPr>
-            <a:r>
-              <a:rPr lang="en-US" sz="900" dirty="0">
-                <a:solidFill>
-                  <a:srgbClr val="9AA4B2"/>
-                </a:solidFill>
-                <a:latin typeface="Consolas" pitchFamily="34" charset="0"/>
-                <a:ea typeface="Consolas" pitchFamily="34" charset="-122"/>
-                <a:cs typeface="Consolas" pitchFamily="34" charset="-120"/>
-              </a:rPr>
-              <a:t>shots/hero-result.png</a:t>
-            </a:r>
-            <a:endParaRPr lang="en-US" sz="1200" dirty="0"/>
-          </a:p>
-        </p:txBody>
       </p:sp>
     </p:spTree>
   </p:cSld>
@@ -9607,44 +9567,82 @@
           </a:p>
         </p:txBody>
       </p:sp>
-      <p:sp>
-        <p:nvSpPr>
-          <p:cNvPr id="9" name="Text 6"/>
-          <p:cNvSpPr/>
-          <p:nvPr/>
-        </p:nvSpPr>
-        <p:spPr>
-          <a:xfrm>
-            <a:off x="548640" y="1600200"/>
-            <a:ext cx="2011680" cy="4160520"/>
-          </a:xfrm>
-          <a:prstGeom prst="roundRect">
-            <a:avLst>
-              <a:gd name="adj" fmla="val 5455"/>
-            </a:avLst>
+      <p:pic>
+        <p:nvPicPr>
+          <p:cNvPr id="9" name="Image 1" descr="Collect">    </p:cNvPr>
+          <p:cNvPicPr>
+            <a:picLocks noChangeAspect="1"/>
+          </p:cNvPicPr>
+          <p:nvPr/>
+        </p:nvPicPr>
+        <p:blipFill>
+          <a:blip r:embed="rId2"/>
+          <a:srcRect l="0" r="0" t="0" b="0"/>
+          <a:stretch/>
+        </p:blipFill>
+        <p:spPr>
+          <a:xfrm>
+            <a:off x="548640" y="1783080"/>
+            <a:ext cx="2011680" cy="3562691"/>
+          </a:xfrm>
+          <a:prstGeom prst="rect">
+            <a:avLst/>
+          </a:prstGeom>
+        </p:spPr>
+      </p:pic>
+      <p:sp>
+        <p:nvSpPr>
+          <p:cNvPr id="10" name="Shape 6"/>
+          <p:cNvSpPr/>
+          <p:nvPr/>
+        </p:nvSpPr>
+        <p:spPr>
+          <a:xfrm>
+            <a:off x="548640" y="1783080"/>
+            <a:ext cx="2011680" cy="3562691"/>
+          </a:xfrm>
+          <a:prstGeom prst="rect">
+            <a:avLst/>
           </a:prstGeom>
           <a:solidFill>
-            <a:srgbClr val="F2F4F7"/>
+            <a:srgbClr val="FFFFFF">
+              <a:alpha val="0"/>
+            </a:srgbClr>
           </a:solidFill>
-          <a:ln w="12700">
+          <a:ln w="9525">
             <a:solidFill>
-              <a:srgbClr val="9AA4B2"/>
+              <a:srgbClr val="D9DEE4"/>
             </a:solidFill>
-            <a:prstDash val="dash"/>
+            <a:prstDash val="solid"/>
           </a:ln>
         </p:spPr>
-        <p:txBody>
-          <a:bodyPr wrap="square" lIns="101600" tIns="101600" rIns="101600" bIns="101600" rtlCol="0" anchor="ctr"/>
+      </p:sp>
+      <p:sp>
+        <p:nvSpPr>
+          <p:cNvPr id="11" name="Text 7"/>
+          <p:cNvSpPr/>
+          <p:nvPr/>
+        </p:nvSpPr>
+        <p:spPr>
+          <a:xfrm>
+            <a:off x="548640" y="5437211"/>
+            <a:ext cx="2011680" cy="274320"/>
+          </a:xfrm>
+          <a:prstGeom prst="rect">
+            <a:avLst/>
+          </a:prstGeom>
+          <a:noFill/>
+          <a:ln/>
+        </p:spPr>
+        <p:txBody>
+          <a:bodyPr wrap="square" lIns="0" tIns="0" rIns="0" bIns="0" rtlCol="0" anchor="ctr"/>
           <a:lstStyle/>
           <a:p>
             <a:pPr algn="ctr" indent="0" marL="0">
-              <a:spcAft>
-                <a:spcPts val="400"/>
-              </a:spcAft>
-              <a:buNone/>
-            </a:pPr>
-            <a:r>
-              <a:rPr lang="en-US" sz="1200" dirty="0">
+              <a:buNone/>
+            </a:pPr>
+            <a:r>
+              <a:rPr lang="en-US" sz="1100" dirty="0">
                 <a:solidFill>
                   <a:srgbClr val="5B6470"/>
                 </a:solidFill>
@@ -9652,61 +9650,71 @@
                 <a:ea typeface="Segoe UI Semibold" pitchFamily="34" charset="-122"/>
                 <a:cs typeface="Segoe UI Semibold" pitchFamily="34" charset="-120"/>
               </a:rPr>
-              <a:t>Collect</a:t>
-            </a:r>
-            <a:endParaRPr lang="en-US" sz="1200" dirty="0"/>
-          </a:p>
-          <a:p>
-            <a:pPr algn="ctr" indent="0" marL="0">
-              <a:spcAft>
-                <a:spcPts val="400"/>
-              </a:spcAft>
-              <a:buNone/>
-            </a:pPr>
-            <a:r>
-              <a:rPr lang="en-US" sz="1000" dirty="0">
-                <a:solidFill>
-                  <a:srgbClr val="5B6470"/>
-                </a:solidFill>
-                <a:latin typeface="Segoe UI" pitchFamily="34" charset="0"/>
-                <a:ea typeface="Segoe UI" pitchFamily="34" charset="-122"/>
-                <a:cs typeface="Segoe UI" pitchFamily="34" charset="-120"/>
-              </a:rPr>
-              <a:t>Collect screen: upload, SMS box, "Try with demo data"</a:t>
-            </a:r>
-            <a:endParaRPr lang="en-US" sz="1200" dirty="0"/>
-          </a:p>
-          <a:p>
-            <a:pPr algn="ctr" indent="0" marL="0">
-              <a:spcAft>
-                <a:spcPts val="400"/>
-              </a:spcAft>
-              <a:buNone/>
-            </a:pPr>
-            <a:r>
-              <a:rPr lang="en-US" sz="900" dirty="0">
-                <a:solidFill>
-                  <a:srgbClr val="9AA4B2"/>
-                </a:solidFill>
-                <a:latin typeface="Consolas" pitchFamily="34" charset="0"/>
-                <a:ea typeface="Consolas" pitchFamily="34" charset="-122"/>
-                <a:cs typeface="Consolas" pitchFamily="34" charset="-120"/>
-              </a:rPr>
-              <a:t>shots/shot-collect.png</a:t>
-            </a:r>
-            <a:endParaRPr lang="en-US" sz="1200" dirty="0"/>
-          </a:p>
-        </p:txBody>
-      </p:sp>
-      <p:sp>
-        <p:nvSpPr>
-          <p:cNvPr id="10" name="Text 7"/>
-          <p:cNvSpPr/>
-          <p:nvPr/>
-        </p:nvSpPr>
-        <p:spPr>
-          <a:xfrm>
-            <a:off x="548640" y="5852160"/>
+              <a:t>1  Collect</a:t>
+            </a:r>
+            <a:endParaRPr lang="en-US" sz="1100" dirty="0"/>
+          </a:p>
+        </p:txBody>
+      </p:sp>
+      <p:pic>
+        <p:nvPicPr>
+          <p:cNvPr id="12" name="Image 2" descr="Confirm">    </p:cNvPr>
+          <p:cNvPicPr>
+            <a:picLocks noChangeAspect="1"/>
+          </p:cNvPicPr>
+          <p:nvPr/>
+        </p:nvPicPr>
+        <p:blipFill>
+          <a:blip r:embed="rId3"/>
+          <a:srcRect l="0" r="0" t="0" b="0"/>
+          <a:stretch/>
+        </p:blipFill>
+        <p:spPr>
+          <a:xfrm>
+            <a:off x="2788920" y="1783080"/>
+            <a:ext cx="2011680" cy="3562691"/>
+          </a:xfrm>
+          <a:prstGeom prst="rect">
+            <a:avLst/>
+          </a:prstGeom>
+        </p:spPr>
+      </p:pic>
+      <p:sp>
+        <p:nvSpPr>
+          <p:cNvPr id="13" name="Shape 8"/>
+          <p:cNvSpPr/>
+          <p:nvPr/>
+        </p:nvSpPr>
+        <p:spPr>
+          <a:xfrm>
+            <a:off x="2788920" y="1783080"/>
+            <a:ext cx="2011680" cy="3562691"/>
+          </a:xfrm>
+          <a:prstGeom prst="rect">
+            <a:avLst/>
+          </a:prstGeom>
+          <a:solidFill>
+            <a:srgbClr val="FFFFFF">
+              <a:alpha val="0"/>
+            </a:srgbClr>
+          </a:solidFill>
+          <a:ln w="9525">
+            <a:solidFill>
+              <a:srgbClr val="D9DEE4"/>
+            </a:solidFill>
+            <a:prstDash val="solid"/>
+          </a:ln>
+        </p:spPr>
+      </p:sp>
+      <p:sp>
+        <p:nvSpPr>
+          <p:cNvPr id="14" name="Text 9"/>
+          <p:cNvSpPr/>
+          <p:nvPr/>
+        </p:nvSpPr>
+        <p:spPr>
+          <a:xfrm>
+            <a:off x="2788920" y="5437211"/>
             <a:ext cx="2011680" cy="274320"/>
           </a:xfrm>
           <a:prstGeom prst="rect">
@@ -9731,50 +9739,88 @@
                 <a:ea typeface="Segoe UI Semibold" pitchFamily="34" charset="-122"/>
                 <a:cs typeface="Segoe UI Semibold" pitchFamily="34" charset="-120"/>
               </a:rPr>
-              <a:t>1  Collect</a:t>
+              <a:t>2  Confirm</a:t>
             </a:r>
             <a:endParaRPr lang="en-US" sz="1100" dirty="0"/>
           </a:p>
         </p:txBody>
       </p:sp>
-      <p:sp>
-        <p:nvSpPr>
-          <p:cNvPr id="11" name="Text 8"/>
-          <p:cNvSpPr/>
-          <p:nvPr/>
-        </p:nvSpPr>
-        <p:spPr>
-          <a:xfrm>
-            <a:off x="2788920" y="1600200"/>
-            <a:ext cx="2011680" cy="4160520"/>
-          </a:xfrm>
-          <a:prstGeom prst="roundRect">
-            <a:avLst>
-              <a:gd name="adj" fmla="val 5455"/>
-            </a:avLst>
+      <p:pic>
+        <p:nvPicPr>
+          <p:cNvPr id="15" name="Image 3" descr="Docket">    </p:cNvPr>
+          <p:cNvPicPr>
+            <a:picLocks noChangeAspect="1"/>
+          </p:cNvPicPr>
+          <p:nvPr/>
+        </p:nvPicPr>
+        <p:blipFill>
+          <a:blip r:embed="rId4"/>
+          <a:srcRect l="0" r="0" t="0" b="0"/>
+          <a:stretch/>
+        </p:blipFill>
+        <p:spPr>
+          <a:xfrm>
+            <a:off x="5029200" y="1783080"/>
+            <a:ext cx="2011680" cy="3562691"/>
+          </a:xfrm>
+          <a:prstGeom prst="rect">
+            <a:avLst/>
+          </a:prstGeom>
+        </p:spPr>
+      </p:pic>
+      <p:sp>
+        <p:nvSpPr>
+          <p:cNvPr id="16" name="Shape 10"/>
+          <p:cNvSpPr/>
+          <p:nvPr/>
+        </p:nvSpPr>
+        <p:spPr>
+          <a:xfrm>
+            <a:off x="5029200" y="1783080"/>
+            <a:ext cx="2011680" cy="3562691"/>
+          </a:xfrm>
+          <a:prstGeom prst="rect">
+            <a:avLst/>
           </a:prstGeom>
           <a:solidFill>
-            <a:srgbClr val="F2F4F7"/>
+            <a:srgbClr val="FFFFFF">
+              <a:alpha val="0"/>
+            </a:srgbClr>
           </a:solidFill>
-          <a:ln w="12700">
+          <a:ln w="9525">
             <a:solidFill>
-              <a:srgbClr val="9AA4B2"/>
+              <a:srgbClr val="D9DEE4"/>
             </a:solidFill>
-            <a:prstDash val="dash"/>
+            <a:prstDash val="solid"/>
           </a:ln>
         </p:spPr>
-        <p:txBody>
-          <a:bodyPr wrap="square" lIns="101600" tIns="101600" rIns="101600" bIns="101600" rtlCol="0" anchor="ctr"/>
+      </p:sp>
+      <p:sp>
+        <p:nvSpPr>
+          <p:cNvPr id="17" name="Text 11"/>
+          <p:cNvSpPr/>
+          <p:nvPr/>
+        </p:nvSpPr>
+        <p:spPr>
+          <a:xfrm>
+            <a:off x="5029200" y="5437211"/>
+            <a:ext cx="2011680" cy="274320"/>
+          </a:xfrm>
+          <a:prstGeom prst="rect">
+            <a:avLst/>
+          </a:prstGeom>
+          <a:noFill/>
+          <a:ln/>
+        </p:spPr>
+        <p:txBody>
+          <a:bodyPr wrap="square" lIns="0" tIns="0" rIns="0" bIns="0" rtlCol="0" anchor="ctr"/>
           <a:lstStyle/>
           <a:p>
             <a:pPr algn="ctr" indent="0" marL="0">
-              <a:spcAft>
-                <a:spcPts val="400"/>
-              </a:spcAft>
-              <a:buNone/>
-            </a:pPr>
-            <a:r>
-              <a:rPr lang="en-US" sz="1200" dirty="0">
+              <a:buNone/>
+            </a:pPr>
+            <a:r>
+              <a:rPr lang="en-US" sz="1100" dirty="0">
                 <a:solidFill>
                   <a:srgbClr val="5B6470"/>
                 </a:solidFill>
@@ -9782,62 +9828,22 @@
                 <a:ea typeface="Segoe UI Semibold" pitchFamily="34" charset="-122"/>
                 <a:cs typeface="Segoe UI Semibold" pitchFamily="34" charset="-120"/>
               </a:rPr>
-              <a:t>Confirm</a:t>
-            </a:r>
-            <a:endParaRPr lang="en-US" sz="1200" dirty="0"/>
-          </a:p>
-          <a:p>
-            <a:pPr algn="ctr" indent="0" marL="0">
-              <a:spcAft>
-                <a:spcPts val="400"/>
-              </a:spcAft>
-              <a:buNone/>
-            </a:pPr>
-            <a:r>
-              <a:rPr lang="en-US" sz="1000" dirty="0">
-                <a:solidFill>
-                  <a:srgbClr val="5B6470"/>
-                </a:solidFill>
-                <a:latin typeface="Segoe UI" pitchFamily="34" charset="0"/>
-                <a:ea typeface="Segoe UI" pitchFamily="34" charset="-122"/>
-                <a:cs typeface="Segoe UI" pitchFamily="34" charset="-120"/>
-              </a:rPr>
-              <a:t>Confirm screen: thumbnails + editable numbers + bank credits</a:t>
-            </a:r>
-            <a:endParaRPr lang="en-US" sz="1200" dirty="0"/>
-          </a:p>
-          <a:p>
-            <a:pPr algn="ctr" indent="0" marL="0">
-              <a:spcAft>
-                <a:spcPts val="400"/>
-              </a:spcAft>
-              <a:buNone/>
-            </a:pPr>
-            <a:r>
-              <a:rPr lang="en-US" sz="900" dirty="0">
-                <a:solidFill>
-                  <a:srgbClr val="9AA4B2"/>
-                </a:solidFill>
-                <a:latin typeface="Consolas" pitchFamily="34" charset="0"/>
-                <a:ea typeface="Consolas" pitchFamily="34" charset="-122"/>
-                <a:cs typeface="Consolas" pitchFamily="34" charset="-120"/>
-              </a:rPr>
-              <a:t>shots/shot-confirm.png</a:t>
-            </a:r>
-            <a:endParaRPr lang="en-US" sz="1200" dirty="0"/>
-          </a:p>
-        </p:txBody>
-      </p:sp>
-      <p:sp>
-        <p:nvSpPr>
-          <p:cNvPr id="12" name="Text 9"/>
-          <p:cNvSpPr/>
-          <p:nvPr/>
-        </p:nvSpPr>
-        <p:spPr>
-          <a:xfrm>
-            <a:off x="2788920" y="5852160"/>
-            <a:ext cx="2011680" cy="274320"/>
+              <a:t>3  Docket</a:t>
+            </a:r>
+            <a:endParaRPr lang="en-US" sz="1100" dirty="0"/>
+          </a:p>
+        </p:txBody>
+      </p:sp>
+      <p:sp>
+        <p:nvSpPr>
+          <p:cNvPr id="18" name="Text 12"/>
+          <p:cNvSpPr/>
+          <p:nvPr/>
+        </p:nvSpPr>
+        <p:spPr>
+          <a:xfrm>
+            <a:off x="7498080" y="1600200"/>
+            <a:ext cx="4144975" cy="256032"/>
           </a:xfrm>
           <a:prstGeom prst="rect">
             <a:avLst/>
@@ -9849,187 +9855,18 @@
           <a:bodyPr wrap="square" lIns="0" tIns="0" rIns="0" bIns="0" rtlCol="0" anchor="ctr"/>
           <a:lstStyle/>
           <a:p>
-            <a:pPr algn="ctr" indent="0" marL="0">
-              <a:buNone/>
-            </a:pPr>
-            <a:r>
-              <a:rPr lang="en-US" sz="1100" dirty="0">
-                <a:solidFill>
-                  <a:srgbClr val="5B6470"/>
+            <a:pPr indent="0" marL="0">
+              <a:buNone/>
+            </a:pPr>
+            <a:r>
+              <a:rPr lang="en-US" sz="1050" spc="200" kern="0" dirty="0">
+                <a:solidFill>
+                  <a:srgbClr val="0B5CAD"/>
                 </a:solidFill>
                 <a:latin typeface="Segoe UI Semibold" pitchFamily="34" charset="0"/>
                 <a:ea typeface="Segoe UI Semibold" pitchFamily="34" charset="-122"/>
                 <a:cs typeface="Segoe UI Semibold" pitchFamily="34" charset="-120"/>
               </a:rPr>
-              <a:t>2  Confirm</a:t>
-            </a:r>
-            <a:endParaRPr lang="en-US" sz="1100" dirty="0"/>
-          </a:p>
-        </p:txBody>
-      </p:sp>
-      <p:sp>
-        <p:nvSpPr>
-          <p:cNvPr id="13" name="Text 10"/>
-          <p:cNvSpPr/>
-          <p:nvPr/>
-        </p:nvSpPr>
-        <p:spPr>
-          <a:xfrm>
-            <a:off x="5029200" y="1600200"/>
-            <a:ext cx="2011680" cy="4160520"/>
-          </a:xfrm>
-          <a:prstGeom prst="roundRect">
-            <a:avLst>
-              <a:gd name="adj" fmla="val 5455"/>
-            </a:avLst>
-          </a:prstGeom>
-          <a:solidFill>
-            <a:srgbClr val="F2F4F7"/>
-          </a:solidFill>
-          <a:ln w="12700">
-            <a:solidFill>
-              <a:srgbClr val="9AA4B2"/>
-            </a:solidFill>
-            <a:prstDash val="dash"/>
-          </a:ln>
-        </p:spPr>
-        <p:txBody>
-          <a:bodyPr wrap="square" lIns="101600" tIns="101600" rIns="101600" bIns="101600" rtlCol="0" anchor="ctr"/>
-          <a:lstStyle/>
-          <a:p>
-            <a:pPr algn="ctr" indent="0" marL="0">
-              <a:spcAft>
-                <a:spcPts val="400"/>
-              </a:spcAft>
-              <a:buNone/>
-            </a:pPr>
-            <a:r>
-              <a:rPr lang="en-US" sz="1200" dirty="0">
-                <a:solidFill>
-                  <a:srgbClr val="5B6470"/>
-                </a:solidFill>
-                <a:latin typeface="Segoe UI Semibold" pitchFamily="34" charset="0"/>
-                <a:ea typeface="Segoe UI Semibold" pitchFamily="34" charset="-122"/>
-                <a:cs typeface="Segoe UI Semibold" pitchFamily="34" charset="-120"/>
-              </a:rPr>
-              <a:t>Docket</a:t>
-            </a:r>
-            <a:endParaRPr lang="en-US" sz="1200" dirty="0"/>
-          </a:p>
-          <a:p>
-            <a:pPr algn="ctr" indent="0" marL="0">
-              <a:spcAft>
-                <a:spcPts val="400"/>
-              </a:spcAft>
-              <a:buNone/>
-            </a:pPr>
-            <a:r>
-              <a:rPr lang="en-US" sz="1000" dirty="0">
-                <a:solidFill>
-                  <a:srgbClr val="5B6470"/>
-                </a:solidFill>
-                <a:latin typeface="Segoe UI" pitchFamily="34" charset="0"/>
-                <a:ea typeface="Segoe UI" pitchFamily="34" charset="-122"/>
-                <a:cs typeface="Segoe UI" pitchFamily="34" charset="-120"/>
-              </a:rPr>
-              <a:t>Result screen: finding cards with arithmetic</a:t>
-            </a:r>
-            <a:endParaRPr lang="en-US" sz="1200" dirty="0"/>
-          </a:p>
-          <a:p>
-            <a:pPr algn="ctr" indent="0" marL="0">
-              <a:spcAft>
-                <a:spcPts val="400"/>
-              </a:spcAft>
-              <a:buNone/>
-            </a:pPr>
-            <a:r>
-              <a:rPr lang="en-US" sz="900" dirty="0">
-                <a:solidFill>
-                  <a:srgbClr val="9AA4B2"/>
-                </a:solidFill>
-                <a:latin typeface="Consolas" pitchFamily="34" charset="0"/>
-                <a:ea typeface="Consolas" pitchFamily="34" charset="-122"/>
-                <a:cs typeface="Consolas" pitchFamily="34" charset="-120"/>
-              </a:rPr>
-              <a:t>shots/shot-result.png</a:t>
-            </a:r>
-            <a:endParaRPr lang="en-US" sz="1200" dirty="0"/>
-          </a:p>
-        </p:txBody>
-      </p:sp>
-      <p:sp>
-        <p:nvSpPr>
-          <p:cNvPr id="14" name="Text 11"/>
-          <p:cNvSpPr/>
-          <p:nvPr/>
-        </p:nvSpPr>
-        <p:spPr>
-          <a:xfrm>
-            <a:off x="5029200" y="5852160"/>
-            <a:ext cx="2011680" cy="274320"/>
-          </a:xfrm>
-          <a:prstGeom prst="rect">
-            <a:avLst/>
-          </a:prstGeom>
-          <a:noFill/>
-          <a:ln/>
-        </p:spPr>
-        <p:txBody>
-          <a:bodyPr wrap="square" lIns="0" tIns="0" rIns="0" bIns="0" rtlCol="0" anchor="ctr"/>
-          <a:lstStyle/>
-          <a:p>
-            <a:pPr algn="ctr" indent="0" marL="0">
-              <a:buNone/>
-            </a:pPr>
-            <a:r>
-              <a:rPr lang="en-US" sz="1100" dirty="0">
-                <a:solidFill>
-                  <a:srgbClr val="5B6470"/>
-                </a:solidFill>
-                <a:latin typeface="Segoe UI Semibold" pitchFamily="34" charset="0"/>
-                <a:ea typeface="Segoe UI Semibold" pitchFamily="34" charset="-122"/>
-                <a:cs typeface="Segoe UI Semibold" pitchFamily="34" charset="-120"/>
-              </a:rPr>
-              <a:t>3  Docket</a:t>
-            </a:r>
-            <a:endParaRPr lang="en-US" sz="1100" dirty="0"/>
-          </a:p>
-        </p:txBody>
-      </p:sp>
-      <p:sp>
-        <p:nvSpPr>
-          <p:cNvPr id="15" name="Text 12"/>
-          <p:cNvSpPr/>
-          <p:nvPr/>
-        </p:nvSpPr>
-        <p:spPr>
-          <a:xfrm>
-            <a:off x="7498080" y="1600200"/>
-            <a:ext cx="4144975" cy="256032"/>
-          </a:xfrm>
-          <a:prstGeom prst="rect">
-            <a:avLst/>
-          </a:prstGeom>
-          <a:noFill/>
-          <a:ln/>
-        </p:spPr>
-        <p:txBody>
-          <a:bodyPr wrap="square" lIns="0" tIns="0" rIns="0" bIns="0" rtlCol="0" anchor="ctr"/>
-          <a:lstStyle/>
-          <a:p>
-            <a:pPr indent="0" marL="0">
-              <a:buNone/>
-            </a:pPr>
-            <a:r>
-              <a:rPr lang="en-US" sz="1050" spc="200" kern="0" dirty="0">
-                <a:solidFill>
-                  <a:srgbClr val="0B5CAD"/>
-                </a:solidFill>
-                <a:latin typeface="Segoe UI Semibold" pitchFamily="34" charset="0"/>
-                <a:ea typeface="Segoe UI Semibold" pitchFamily="34" charset="-122"/>
-                <a:cs typeface="Segoe UI Semibold" pitchFamily="34" charset="-120"/>
-              </a:rPr>
               <a:t>WHAT IT FOUND  (SYNTHETIC DATA)</a:t>
             </a:r>
             <a:endParaRPr lang="en-US" sz="1050" dirty="0"/>
@@ -10038,7 +9875,7 @@
       </p:sp>
       <p:sp>
         <p:nvSpPr>
-          <p:cNvPr id="16" name="Text 13"/>
+          <p:cNvPr id="19" name="Text 13"/>
           <p:cNvSpPr/>
           <p:nvPr/>
         </p:nvSpPr>
@@ -10087,7 +9924,7 @@
       </p:sp>
       <p:sp>
         <p:nvSpPr>
-          <p:cNvPr id="17" name="Text 14"/>
+          <p:cNvPr id="20" name="Text 14"/>
           <p:cNvSpPr/>
           <p:nvPr/>
         </p:nvSpPr>
@@ -10140,7 +9977,7 @@
       </p:sp>
       <p:sp>
         <p:nvSpPr>
-          <p:cNvPr id="18" name="Text 15"/>
+          <p:cNvPr id="21" name="Text 15"/>
           <p:cNvSpPr/>
           <p:nvPr/>
         </p:nvSpPr>
@@ -10189,7 +10026,7 @@
       </p:sp>
       <p:sp>
         <p:nvSpPr>
-          <p:cNvPr id="19" name="Text 16"/>
+          <p:cNvPr id="22" name="Text 16"/>
           <p:cNvSpPr/>
           <p:nvPr/>
         </p:nvSpPr>
@@ -10242,7 +10079,7 @@
       </p:sp>
       <p:sp>
         <p:nvSpPr>
-          <p:cNvPr id="20" name="Text 17"/>
+          <p:cNvPr id="23" name="Text 17"/>
           <p:cNvSpPr/>
           <p:nvPr/>
         </p:nvSpPr>
@@ -10291,7 +10128,7 @@
       </p:sp>
       <p:sp>
         <p:nvSpPr>
-          <p:cNvPr id="21" name="Text 18"/>
+          <p:cNvPr id="24" name="Text 18"/>
           <p:cNvSpPr/>
           <p:nvPr/>
         </p:nvSpPr>
@@ -10344,7 +10181,7 @@
       </p:sp>
       <p:sp>
         <p:nvSpPr>
-          <p:cNvPr id="22" name="Text 19"/>
+          <p:cNvPr id="25" name="Text 19"/>
           <p:cNvSpPr/>
           <p:nvPr/>
         </p:nvSpPr>
@@ -10393,7 +10230,7 @@
       </p:sp>
       <p:sp>
         <p:nvSpPr>
-          <p:cNvPr id="23" name="Text 20"/>
+          <p:cNvPr id="26" name="Text 20"/>
           <p:cNvSpPr/>
           <p:nvPr/>
         </p:nvSpPr>
@@ -10446,7 +10283,7 @@
       </p:sp>
       <p:sp>
         <p:nvSpPr>
-          <p:cNvPr id="24" name="Text 21"/>
+          <p:cNvPr id="27" name="Text 21"/>
           <p:cNvSpPr/>
           <p:nvPr/>
         </p:nvSpPr>
@@ -10495,7 +10332,7 @@
       </p:sp>
       <p:sp>
         <p:nvSpPr>
-          <p:cNvPr id="25" name="Text 22"/>
+          <p:cNvPr id="28" name="Text 22"/>
           <p:cNvSpPr/>
           <p:nvPr/>
         </p:nvSpPr>
@@ -10548,7 +10385,7 @@
       </p:sp>
       <p:sp>
         <p:nvSpPr>
-          <p:cNvPr id="26" name="Shape 23"/>
+          <p:cNvPr id="29" name="Shape 23"/>
           <p:cNvSpPr/>
           <p:nvPr/>
         </p:nvSpPr>
@@ -10571,7 +10408,7 @@
       </p:sp>
       <p:sp>
         <p:nvSpPr>
-          <p:cNvPr id="27" name="Text 24"/>
+          <p:cNvPr id="30" name="Text 24"/>
           <p:cNvSpPr/>
           <p:nvPr/>
         </p:nvSpPr>

</xml_diff>